<commit_message>
Update animated presentation to final app: hosted sign-in, installer link, honest match percentages
</commit_message>
<xml_diff>
--- a/docs/NextRole-Presentation.pptx
+++ b/docs/NextRole-Presentation.pptx
@@ -1658,7 +1658,7 @@
     <p:bg>
       <p:bgPr>
         <a:solidFill>
-          <a:srgbClr val="11372A"/>
+          <a:srgbClr val="123A2B"/>
         </a:solidFill>
       </p:bgPr>
     </p:bg>
@@ -1691,7 +1691,7 @@
             <a:avLst/>
           </a:prstGeom>
           <a:solidFill>
-            <a:srgbClr val="E2603B"/>
+            <a:srgbClr val="E2603C"/>
           </a:solidFill>
           <a:ln/>
         </p:spPr>
@@ -1704,7 +1704,7 @@
         </p:nvSpPr>
         <p:spPr>
           <a:xfrm>
-            <a:off x="822960" y="1828800"/>
+            <a:off x="822960" y="1600200"/>
             <a:ext cx="10515600" cy="1005840"/>
           </a:xfrm>
           <a:prstGeom prst="rect">
@@ -1743,7 +1743,7 @@
         </p:nvSpPr>
         <p:spPr>
           <a:xfrm>
-            <a:off x="822960" y="2788920"/>
+            <a:off x="822960" y="2560320"/>
             <a:ext cx="10515600" cy="731520"/>
           </a:xfrm>
           <a:prstGeom prst="rect">
@@ -1762,7 +1762,7 @@
             <a:r>
               <a:rPr lang="en-US" sz="3000" dirty="0">
                 <a:solidFill>
-                  <a:srgbClr val="ECE9DB"/>
+                  <a:srgbClr val="F1EFE6"/>
                 </a:solidFill>
                 <a:latin typeface="Segoe UI" pitchFamily="34" charset="0"/>
                 <a:ea typeface="Segoe UI" pitchFamily="34" charset="-122"/>
@@ -1782,7 +1782,7 @@
         </p:nvSpPr>
         <p:spPr>
           <a:xfrm>
-            <a:off x="822960" y="3611880"/>
+            <a:off x="822960" y="3383280"/>
             <a:ext cx="9601200" cy="548640"/>
           </a:xfrm>
           <a:prstGeom prst="rect">
@@ -1821,7 +1821,7 @@
         </p:nvSpPr>
         <p:spPr>
           <a:xfrm>
-            <a:off x="822960" y="4663440"/>
+            <a:off x="822960" y="4343400"/>
             <a:ext cx="1371600" cy="502920"/>
           </a:xfrm>
           <a:prstGeom prst="roundRect">
@@ -1830,7 +1830,7 @@
             </a:avLst>
           </a:prstGeom>
           <a:solidFill>
-            <a:srgbClr val="0C2419"/>
+            <a:srgbClr val="0D2C20"/>
           </a:solidFill>
           <a:ln/>
         </p:spPr>
@@ -1843,7 +1843,7 @@
         </p:nvSpPr>
         <p:spPr>
           <a:xfrm>
-            <a:off x="822960" y="4663440"/>
+            <a:off x="822960" y="4343400"/>
             <a:ext cx="1371600" cy="502920"/>
           </a:xfrm>
           <a:prstGeom prst="rect">
@@ -1862,7 +1862,7 @@
             <a:r>
               <a:rPr lang="en-US" sz="1300" b="1" dirty="0">
                 <a:solidFill>
-                  <a:srgbClr val="ECE9DB"/>
+                  <a:srgbClr val="F1EFE6"/>
                 </a:solidFill>
                 <a:latin typeface="Segoe UI" pitchFamily="34" charset="0"/>
                 <a:ea typeface="Segoe UI" pitchFamily="34" charset="-122"/>
@@ -1882,7 +1882,7 @@
         </p:nvSpPr>
         <p:spPr>
           <a:xfrm>
-            <a:off x="2331720" y="4663440"/>
+            <a:off x="2331720" y="4343400"/>
             <a:ext cx="2011680" cy="502920"/>
           </a:xfrm>
           <a:prstGeom prst="roundRect">
@@ -1891,7 +1891,7 @@
             </a:avLst>
           </a:prstGeom>
           <a:solidFill>
-            <a:srgbClr val="0C2419"/>
+            <a:srgbClr val="0D2C20"/>
           </a:solidFill>
           <a:ln/>
         </p:spPr>
@@ -1904,7 +1904,7 @@
         </p:nvSpPr>
         <p:spPr>
           <a:xfrm>
-            <a:off x="2331720" y="4663440"/>
+            <a:off x="2331720" y="4343400"/>
             <a:ext cx="2011680" cy="502920"/>
           </a:xfrm>
           <a:prstGeom prst="rect">
@@ -1923,7 +1923,7 @@
             <a:r>
               <a:rPr lang="en-US" sz="1300" b="1" dirty="0">
                 <a:solidFill>
-                  <a:srgbClr val="ECE9DB"/>
+                  <a:srgbClr val="F1EFE6"/>
                 </a:solidFill>
                 <a:latin typeface="Segoe UI" pitchFamily="34" charset="0"/>
                 <a:ea typeface="Segoe UI" pitchFamily="34" charset="-122"/>
@@ -1943,7 +1943,7 @@
         </p:nvSpPr>
         <p:spPr>
           <a:xfrm>
-            <a:off x="4480560" y="4663440"/>
+            <a:off x="4480560" y="4343400"/>
             <a:ext cx="1645920" cy="502920"/>
           </a:xfrm>
           <a:prstGeom prst="roundRect">
@@ -1952,7 +1952,7 @@
             </a:avLst>
           </a:prstGeom>
           <a:solidFill>
-            <a:srgbClr val="0C2419"/>
+            <a:srgbClr val="0D2C20"/>
           </a:solidFill>
           <a:ln/>
         </p:spPr>
@@ -1965,7 +1965,7 @@
         </p:nvSpPr>
         <p:spPr>
           <a:xfrm>
-            <a:off x="4480560" y="4663440"/>
+            <a:off x="4480560" y="4343400"/>
             <a:ext cx="1645920" cy="502920"/>
           </a:xfrm>
           <a:prstGeom prst="rect">
@@ -1984,7 +1984,7 @@
             <a:r>
               <a:rPr lang="en-US" sz="1300" b="1" dirty="0">
                 <a:solidFill>
-                  <a:srgbClr val="ECE9DB"/>
+                  <a:srgbClr val="F1EFE6"/>
                 </a:solidFill>
                 <a:latin typeface="Segoe UI" pitchFamily="34" charset="0"/>
                 <a:ea typeface="Segoe UI" pitchFamily="34" charset="-122"/>
@@ -2004,7 +2004,7 @@
         </p:nvSpPr>
         <p:spPr>
           <a:xfrm>
-            <a:off x="6263640" y="4663440"/>
+            <a:off x="6263640" y="4343400"/>
             <a:ext cx="1828800" cy="502920"/>
           </a:xfrm>
           <a:prstGeom prst="roundRect">
@@ -2013,7 +2013,7 @@
             </a:avLst>
           </a:prstGeom>
           <a:solidFill>
-            <a:srgbClr val="0C2419"/>
+            <a:srgbClr val="0D2C20"/>
           </a:solidFill>
           <a:ln/>
         </p:spPr>
@@ -2026,7 +2026,7 @@
         </p:nvSpPr>
         <p:spPr>
           <a:xfrm>
-            <a:off x="6263640" y="4663440"/>
+            <a:off x="6263640" y="4343400"/>
             <a:ext cx="1828800" cy="502920"/>
           </a:xfrm>
           <a:prstGeom prst="rect">
@@ -2045,7 +2045,7 @@
             <a:r>
               <a:rPr lang="en-US" sz="1300" b="1" dirty="0">
                 <a:solidFill>
-                  <a:srgbClr val="ECE9DB"/>
+                  <a:srgbClr val="F1EFE6"/>
                 </a:solidFill>
                 <a:latin typeface="Segoe UI" pitchFamily="34" charset="0"/>
                 <a:ea typeface="Segoe UI" pitchFamily="34" charset="-122"/>
@@ -2065,7 +2065,7 @@
         </p:nvSpPr>
         <p:spPr>
           <a:xfrm>
-            <a:off x="8229600" y="4663440"/>
+            <a:off x="8229600" y="4343400"/>
             <a:ext cx="1463040" cy="502920"/>
           </a:xfrm>
           <a:prstGeom prst="roundRect">
@@ -2074,7 +2074,7 @@
             </a:avLst>
           </a:prstGeom>
           <a:solidFill>
-            <a:srgbClr val="0C2419"/>
+            <a:srgbClr val="0D2C20"/>
           </a:solidFill>
           <a:ln/>
         </p:spPr>
@@ -2087,7 +2087,7 @@
         </p:nvSpPr>
         <p:spPr>
           <a:xfrm>
-            <a:off x="8229600" y="4663440"/>
+            <a:off x="8229600" y="4343400"/>
             <a:ext cx="1463040" cy="502920"/>
           </a:xfrm>
           <a:prstGeom prst="rect">
@@ -2106,7 +2106,7 @@
             <a:r>
               <a:rPr lang="en-US" sz="1300" b="1" dirty="0">
                 <a:solidFill>
-                  <a:srgbClr val="ECE9DB"/>
+                  <a:srgbClr val="F1EFE6"/>
                 </a:solidFill>
                 <a:latin typeface="Segoe UI" pitchFamily="34" charset="0"/>
                 <a:ea typeface="Segoe UI" pitchFamily="34" charset="-122"/>
@@ -2126,7 +2126,7 @@
         </p:nvSpPr>
         <p:spPr>
           <a:xfrm>
-            <a:off x="9829800" y="4663440"/>
+            <a:off x="9829800" y="4343400"/>
             <a:ext cx="1371600" cy="502920"/>
           </a:xfrm>
           <a:prstGeom prst="roundRect">
@@ -2135,7 +2135,7 @@
             </a:avLst>
           </a:prstGeom>
           <a:solidFill>
-            <a:srgbClr val="E2603B"/>
+            <a:srgbClr val="E2603C"/>
           </a:solidFill>
           <a:ln/>
         </p:spPr>
@@ -2148,7 +2148,7 @@
         </p:nvSpPr>
         <p:spPr>
           <a:xfrm>
-            <a:off x="9829800" y="4663440"/>
+            <a:off x="9829800" y="4343400"/>
             <a:ext cx="1371600" cy="502920"/>
           </a:xfrm>
           <a:prstGeom prst="rect">
@@ -2182,6 +2182,45 @@
       <p:sp>
         <p:nvSpPr>
           <p:cNvPr id="18" name="Text 16"/>
+          <p:cNvSpPr/>
+          <p:nvPr/>
+        </p:nvSpPr>
+        <p:spPr>
+          <a:xfrm>
+            <a:off x="822960" y="5394960"/>
+            <a:ext cx="10515600" cy="457200"/>
+          </a:xfrm>
+          <a:prstGeom prst="rect">
+            <a:avLst/>
+          </a:prstGeom>
+          <a:noFill/>
+          <a:ln/>
+        </p:spPr>
+        <p:txBody>
+          <a:bodyPr wrap="square" rtlCol="0" anchor="ctr"/>
+          <a:lstStyle/>
+          <a:p>
+            <a:pPr indent="0" marL="0">
+              <a:buNone/>
+            </a:pPr>
+            <a:r>
+              <a:rPr lang="en-US" sz="1500" dirty="0">
+                <a:solidFill>
+                  <a:srgbClr val="9FB89B"/>
+                </a:solidFill>
+                <a:latin typeface="Segoe UI" pitchFamily="34" charset="0"/>
+                <a:ea typeface="Segoe UI" pitchFamily="34" charset="-122"/>
+                <a:cs typeface="Segoe UI" pitchFamily="34" charset="-120"/>
+              </a:rPr>
+              <a:t>Live on the web  ·  One-click Windows installer  ·  Open source on GitHub</a:t>
+            </a:r>
+            <a:endParaRPr lang="en-US" sz="1500" dirty="0"/>
+          </a:p>
+        </p:txBody>
+      </p:sp>
+      <p:sp>
+        <p:nvSpPr>
+          <p:cNvPr id="19" name="Text 17"/>
           <p:cNvSpPr/>
           <p:nvPr/>
         </p:nvSpPr>
@@ -2206,7 +2245,7 @@
             <a:r>
               <a:rPr lang="en-US" sz="1000" dirty="0">
                 <a:solidFill>
-                  <a:srgbClr val="ECE9DB"/>
+                  <a:srgbClr val="F1EFE6"/>
                 </a:solidFill>
               </a:rPr>
               <a:t>nextrole  ·  1/10</a:t>
@@ -2832,6 +2871,41 @@
                                         <p:cTn id="54" dur="500"/>
                                         <p:tgtEl>
                                           <p:spTgt spid="18"/>
+                                        </p:tgtEl>
+                                      </p:cBhvr>
+                                    </p:animEffect>
+                                  </p:childTnLst>
+                                </p:cTn>
+                              </p:par>
+                              <p:par>
+                                <p:cTn id="56" presetID="10" presetClass="entr" presetSubtype="0" fill="hold" grpId="0" nodeType="withEffect">
+                                  <p:stCondLst>
+                                    <p:cond delay="5950"/>
+                                  </p:stCondLst>
+                                  <p:childTnLst>
+                                    <p:set>
+                                      <p:cBhvr>
+                                        <p:cTn id="55" dur="1" fill="hold">
+                                          <p:stCondLst>
+                                            <p:cond delay="0"/>
+                                          </p:stCondLst>
+                                        </p:cTn>
+                                        <p:tgtEl>
+                                          <p:spTgt spid="19"/>
+                                        </p:tgtEl>
+                                        <p:attrNameLst>
+                                          <p:attrName>style.visibility</p:attrName>
+                                        </p:attrNameLst>
+                                      </p:cBhvr>
+                                      <p:to>
+                                        <p:strVal val="visible"/>
+                                      </p:to>
+                                    </p:set>
+                                    <p:animEffect transition="in" filter="fade">
+                                      <p:cBhvr>
+                                        <p:cTn id="57" dur="500"/>
+                                        <p:tgtEl>
+                                          <p:spTgt spid="19"/>
                                         </p:tgtEl>
                                       </p:cBhvr>
                                     </p:animEffect>
@@ -2875,7 +2949,7 @@
     <p:bg>
       <p:bgPr>
         <a:solidFill>
-          <a:srgbClr val="11372A"/>
+          <a:srgbClr val="123A2B"/>
         </a:solidFill>
       </p:bgPr>
     </p:bg>
@@ -2908,7 +2982,7 @@
             <a:avLst/>
           </a:prstGeom>
           <a:solidFill>
-            <a:srgbClr val="E2603B"/>
+            <a:srgbClr val="E2603C"/>
           </a:solidFill>
           <a:ln/>
         </p:spPr>
@@ -2921,7 +2995,7 @@
         </p:nvSpPr>
         <p:spPr>
           <a:xfrm>
-            <a:off x="822960" y="1280160"/>
+            <a:off x="822960" y="914400"/>
             <a:ext cx="10515600" cy="822960"/>
           </a:xfrm>
           <a:prstGeom prst="rect">
@@ -2946,7 +3020,7 @@
                 <a:ea typeface="Segoe UI" pitchFamily="34" charset="-122"/>
                 <a:cs typeface="Segoe UI" pitchFamily="34" charset="-120"/>
               </a:rPr>
-              <a:t>Live on GitHub</a:t>
+              <a:t>Try it now</a:t>
             </a:r>
             <a:endParaRPr lang="en-US" sz="4000" dirty="0"/>
           </a:p>
@@ -2960,8 +3034,8 @@
         </p:nvSpPr>
         <p:spPr>
           <a:xfrm>
-            <a:off x="822960" y="2194560"/>
-            <a:ext cx="10515600" cy="548640"/>
+            <a:off x="822960" y="1920240"/>
+            <a:ext cx="10789920" cy="457200"/>
           </a:xfrm>
           <a:prstGeom prst="rect">
             <a:avLst/>
@@ -2977,17 +3051,17 @@
               <a:buNone/>
             </a:pPr>
             <a:r>
-              <a:rPr lang="en-US" sz="2200" dirty="0">
+              <a:rPr lang="en-US" sz="1800" dirty="0">
                 <a:solidFill>
-                  <a:srgbClr val="E2603B"/>
+                  <a:srgbClr val="F1EFE6"/>
                 </a:solidFill>
                 <a:latin typeface="Consolas" pitchFamily="34" charset="0"/>
                 <a:ea typeface="Consolas" pitchFamily="34" charset="-122"/>
                 <a:cs typeface="Consolas" pitchFamily="34" charset="-120"/>
               </a:rPr>
-              <a:t>github.com/saxenavansh070-droid/nextrole</a:t>
-            </a:r>
-            <a:endParaRPr lang="en-US" sz="2200" dirty="0"/>
+              <a:t>App:      https://saxenavansh070-droid.github.io/nextrole/</a:t>
+            </a:r>
+            <a:endParaRPr lang="en-US" sz="1800" dirty="0"/>
           </a:p>
         </p:txBody>
       </p:sp>
@@ -2999,7 +3073,85 @@
         </p:nvSpPr>
         <p:spPr>
           <a:xfrm>
-            <a:off x="777240" y="3017520"/>
+            <a:off x="822960" y="2468880"/>
+            <a:ext cx="10789920" cy="457200"/>
+          </a:xfrm>
+          <a:prstGeom prst="rect">
+            <a:avLst/>
+          </a:prstGeom>
+          <a:noFill/>
+          <a:ln/>
+        </p:spPr>
+        <p:txBody>
+          <a:bodyPr wrap="square" rtlCol="0" anchor="ctr"/>
+          <a:lstStyle/>
+          <a:p>
+            <a:pPr indent="0" marL="0">
+              <a:buNone/>
+            </a:pPr>
+            <a:r>
+              <a:rPr lang="en-US" sz="1400" dirty="0">
+                <a:solidFill>
+                  <a:srgbClr val="F1EFE6"/>
+                </a:solidFill>
+                <a:latin typeface="Consolas" pitchFamily="34" charset="0"/>
+                <a:ea typeface="Consolas" pitchFamily="34" charset="-122"/>
+                <a:cs typeface="Consolas" pitchFamily="34" charset="-120"/>
+              </a:rPr>
+              <a:t>Install:  https://github.com/saxenavansh070-droid/nextrole/releases/download/v1.0.0/NextRole-Setup-1.0.0.exe</a:t>
+            </a:r>
+            <a:endParaRPr lang="en-US" sz="1400" dirty="0"/>
+          </a:p>
+        </p:txBody>
+      </p:sp>
+      <p:sp>
+        <p:nvSpPr>
+          <p:cNvPr id="6" name="Text 4"/>
+          <p:cNvSpPr/>
+          <p:nvPr/>
+        </p:nvSpPr>
+        <p:spPr>
+          <a:xfrm>
+            <a:off x="822960" y="3017520"/>
+            <a:ext cx="10789920" cy="457200"/>
+          </a:xfrm>
+          <a:prstGeom prst="rect">
+            <a:avLst/>
+          </a:prstGeom>
+          <a:noFill/>
+          <a:ln/>
+        </p:spPr>
+        <p:txBody>
+          <a:bodyPr wrap="square" rtlCol="0" anchor="ctr"/>
+          <a:lstStyle/>
+          <a:p>
+            <a:pPr indent="0" marL="0">
+              <a:buNone/>
+            </a:pPr>
+            <a:r>
+              <a:rPr lang="en-US" sz="1800" dirty="0">
+                <a:solidFill>
+                  <a:srgbClr val="F1EFE6"/>
+                </a:solidFill>
+                <a:latin typeface="Consolas" pitchFamily="34" charset="0"/>
+                <a:ea typeface="Consolas" pitchFamily="34" charset="-122"/>
+                <a:cs typeface="Consolas" pitchFamily="34" charset="-120"/>
+              </a:rPr>
+              <a:t>Repo:     https://github.com/saxenavansh070-droid/nextrole</a:t>
+            </a:r>
+            <a:endParaRPr lang="en-US" sz="1800" dirty="0"/>
+          </a:p>
+        </p:txBody>
+      </p:sp>
+      <p:sp>
+        <p:nvSpPr>
+          <p:cNvPr id="7" name="Text 5"/>
+          <p:cNvSpPr/>
+          <p:nvPr/>
+        </p:nvSpPr>
+        <p:spPr>
+          <a:xfrm>
+            <a:off x="777240" y="3794760"/>
             <a:ext cx="10515600" cy="4023360"/>
           </a:xfrm>
           <a:prstGeom prst="rect">
@@ -3020,17 +3172,17 @@
               <a:buChar char="•"/>
             </a:pPr>
             <a:r>
-              <a:rPr lang="en-US" sz="1800" dirty="0">
+              <a:rPr lang="en-US" sz="1600" dirty="0">
                 <a:solidFill>
-                  <a:srgbClr val="ECE9DB"/>
+                  <a:srgbClr val="F1EFE6"/>
                 </a:solidFill>
                 <a:latin typeface="Segoe UI" pitchFamily="34" charset="0"/>
                 <a:ea typeface="Segoe UI" pitchFamily="34" charset="-122"/>
                 <a:cs typeface="Segoe UI" pitchFamily="34" charset="-120"/>
               </a:rPr>
-              <a:t>Web app: http://localhost:4000 after npm run build &amp;&amp; npm start</a:t>
-            </a:r>
-            <a:endParaRPr lang="en-US" sz="1800" dirty="0"/>
+              <a:t>Web app runs fully in your browser - sign in, upload, explore, save to your profile.</a:t>
+            </a:r>
+            <a:endParaRPr lang="en-US" sz="1600" dirty="0"/>
           </a:p>
           <a:p>
             <a:pPr marL="228600" indent="-228600">
@@ -3041,17 +3193,17 @@
               <a:buChar char="•"/>
             </a:pPr>
             <a:r>
-              <a:rPr lang="en-US" sz="1800" dirty="0">
+              <a:rPr lang="en-US" sz="1600" dirty="0">
                 <a:solidFill>
-                  <a:srgbClr val="ECE9DB"/>
+                  <a:srgbClr val="F1EFE6"/>
                 </a:solidFill>
                 <a:latin typeface="Segoe UI" pitchFamily="34" charset="0"/>
                 <a:ea typeface="Segoe UI" pitchFamily="34" charset="-122"/>
                 <a:cs typeface="Segoe UI" pitchFamily="34" charset="-120"/>
               </a:rPr>
-              <a:t>Desktop: Next Role.exe (release/win-unpacked) or npm run desktop</a:t>
-            </a:r>
-            <a:endParaRPr lang="en-US" sz="1800" dirty="0"/>
+              <a:t>Installer sets up the desktop app on Windows in one click.</a:t>
+            </a:r>
+            <a:endParaRPr lang="en-US" sz="1600" dirty="0"/>
           </a:p>
           <a:p>
             <a:pPr marL="228600" indent="-228600">
@@ -3062,23 +3214,23 @@
               <a:buChar char="•"/>
             </a:pPr>
             <a:r>
-              <a:rPr lang="en-US" sz="1800" dirty="0">
+              <a:rPr lang="en-US" sz="1600" dirty="0">
                 <a:solidFill>
-                  <a:srgbClr val="ECE9DB"/>
+                  <a:srgbClr val="F1EFE6"/>
                 </a:solidFill>
                 <a:latin typeface="Segoe UI" pitchFamily="34" charset="0"/>
                 <a:ea typeface="Segoe UI" pitchFamily="34" charset="-122"/>
                 <a:cs typeface="Segoe UI" pitchFamily="34" charset="-120"/>
               </a:rPr>
-              <a:t>Docs: README.md with full setup, env vars, and architecture.</a:t>
-            </a:r>
-            <a:endParaRPr lang="en-US" sz="1800" dirty="0"/>
+              <a:t>Docs: README.md with full setup, env vars, and architecture; docs/ has the source-code PDF.</a:t>
+            </a:r>
+            <a:endParaRPr lang="en-US" sz="1600" dirty="0"/>
           </a:p>
         </p:txBody>
       </p:sp>
       <p:sp>
         <p:nvSpPr>
-          <p:cNvPr id="6" name="Text 4"/>
+          <p:cNvPr id="8" name="Text 6"/>
           <p:cNvSpPr/>
           <p:nvPr/>
         </p:nvSpPr>
@@ -3103,7 +3255,7 @@
             <a:r>
               <a:rPr lang="en-US" sz="1800" i="1" dirty="0">
                 <a:solidFill>
-                  <a:srgbClr val="ECE9DB"/>
+                  <a:srgbClr val="F1EFE6"/>
                 </a:solidFill>
                 <a:latin typeface="Segoe UI" pitchFamily="34" charset="0"/>
                 <a:ea typeface="Segoe UI" pitchFamily="34" charset="-122"/>
@@ -3117,7 +3269,7 @@
       </p:sp>
       <p:sp>
         <p:nvSpPr>
-          <p:cNvPr id="7" name="Text 5"/>
+          <p:cNvPr id="9" name="Text 7"/>
           <p:cNvSpPr/>
           <p:nvPr/>
         </p:nvSpPr>
@@ -3142,7 +3294,7 @@
             <a:r>
               <a:rPr lang="en-US" sz="1000" dirty="0">
                 <a:solidFill>
-                  <a:srgbClr val="ECE9DB"/>
+                  <a:srgbClr val="F1EFE6"/>
                 </a:solidFill>
               </a:rPr>
               <a:t>nextrole  ·  10/10</a:t>
@@ -3383,6 +3535,76 @@
                                         <p:cTn id="21" dur="500"/>
                                         <p:tgtEl>
                                           <p:spTgt spid="7"/>
+                                        </p:tgtEl>
+                                      </p:cBhvr>
+                                    </p:animEffect>
+                                  </p:childTnLst>
+                                </p:cTn>
+                              </p:par>
+                              <p:par>
+                                <p:cTn id="23" presetID="10" presetClass="entr" presetSubtype="0" fill="hold" grpId="0" nodeType="withEffect">
+                                  <p:stCondLst>
+                                    <p:cond delay="2100"/>
+                                  </p:stCondLst>
+                                  <p:childTnLst>
+                                    <p:set>
+                                      <p:cBhvr>
+                                        <p:cTn id="22" dur="1" fill="hold">
+                                          <p:stCondLst>
+                                            <p:cond delay="0"/>
+                                          </p:stCondLst>
+                                        </p:cTn>
+                                        <p:tgtEl>
+                                          <p:spTgt spid="8"/>
+                                        </p:tgtEl>
+                                        <p:attrNameLst>
+                                          <p:attrName>style.visibility</p:attrName>
+                                        </p:attrNameLst>
+                                      </p:cBhvr>
+                                      <p:to>
+                                        <p:strVal val="visible"/>
+                                      </p:to>
+                                    </p:set>
+                                    <p:animEffect transition="in" filter="fade">
+                                      <p:cBhvr>
+                                        <p:cTn id="24" dur="500"/>
+                                        <p:tgtEl>
+                                          <p:spTgt spid="8"/>
+                                        </p:tgtEl>
+                                      </p:cBhvr>
+                                    </p:animEffect>
+                                  </p:childTnLst>
+                                </p:cTn>
+                              </p:par>
+                              <p:par>
+                                <p:cTn id="26" presetID="10" presetClass="entr" presetSubtype="0" fill="hold" grpId="0" nodeType="withEffect">
+                                  <p:stCondLst>
+                                    <p:cond delay="2450"/>
+                                  </p:stCondLst>
+                                  <p:childTnLst>
+                                    <p:set>
+                                      <p:cBhvr>
+                                        <p:cTn id="25" dur="1" fill="hold">
+                                          <p:stCondLst>
+                                            <p:cond delay="0"/>
+                                          </p:stCondLst>
+                                        </p:cTn>
+                                        <p:tgtEl>
+                                          <p:spTgt spid="9"/>
+                                        </p:tgtEl>
+                                        <p:attrNameLst>
+                                          <p:attrName>style.visibility</p:attrName>
+                                        </p:attrNameLst>
+                                      </p:cBhvr>
+                                      <p:to>
+                                        <p:strVal val="visible"/>
+                                      </p:to>
+                                    </p:set>
+                                    <p:animEffect transition="in" filter="fade">
+                                      <p:cBhvr>
+                                        <p:cTn id="27" dur="500"/>
+                                        <p:tgtEl>
+                                          <p:spTgt spid="9"/>
                                         </p:tgtEl>
                                       </p:cBhvr>
                                     </p:animEffect>
@@ -3459,7 +3681,7 @@
             <a:avLst/>
           </a:prstGeom>
           <a:solidFill>
-            <a:srgbClr val="E2603B"/>
+            <a:srgbClr val="E2603C"/>
           </a:solidFill>
           <a:ln/>
         </p:spPr>
@@ -3491,7 +3713,7 @@
             <a:r>
               <a:rPr lang="en-US" sz="1300" b="1" spc="300" kern="0" dirty="0">
                 <a:solidFill>
-                  <a:srgbClr val="E2603B"/>
+                  <a:srgbClr val="E2603C"/>
                 </a:solidFill>
                 <a:latin typeface="Segoe UI" pitchFamily="34" charset="0"/>
                 <a:ea typeface="Segoe UI" pitchFamily="34" charset="-122"/>
@@ -3530,7 +3752,7 @@
             <a:r>
               <a:rPr lang="en-US" sz="3400" b="1" dirty="0">
                 <a:solidFill>
-                  <a:srgbClr val="13211B"/>
+                  <a:srgbClr val="11372A"/>
                 </a:solidFill>
                 <a:latin typeface="Segoe UI" pitchFamily="34" charset="0"/>
                 <a:ea typeface="Segoe UI" pitchFamily="34" charset="-122"/>
@@ -3573,7 +3795,7 @@
             <a:r>
               <a:rPr lang="en-US" sz="1800" dirty="0">
                 <a:solidFill>
-                  <a:srgbClr val="13211B"/>
+                  <a:srgbClr val="11372A"/>
                 </a:solidFill>
                 <a:latin typeface="Segoe UI" pitchFamily="34" charset="0"/>
                 <a:ea typeface="Segoe UI" pitchFamily="34" charset="-122"/>
@@ -3594,7 +3816,7 @@
             <a:r>
               <a:rPr lang="en-US" sz="1800" dirty="0">
                 <a:solidFill>
-                  <a:srgbClr val="13211B"/>
+                  <a:srgbClr val="11372A"/>
                 </a:solidFill>
                 <a:latin typeface="Segoe UI" pitchFamily="34" charset="0"/>
                 <a:ea typeface="Segoe UI" pitchFamily="34" charset="-122"/>
@@ -3615,7 +3837,7 @@
             <a:r>
               <a:rPr lang="en-US" sz="1800" dirty="0">
                 <a:solidFill>
-                  <a:srgbClr val="13211B"/>
+                  <a:srgbClr val="11372A"/>
                 </a:solidFill>
                 <a:latin typeface="Segoe UI" pitchFamily="34" charset="0"/>
                 <a:ea typeface="Segoe UI" pitchFamily="34" charset="-122"/>
@@ -3636,7 +3858,7 @@
             <a:r>
               <a:rPr lang="en-US" sz="1800" dirty="0">
                 <a:solidFill>
-                  <a:srgbClr val="13211B"/>
+                  <a:srgbClr val="11372A"/>
                 </a:solidFill>
                 <a:latin typeface="Segoe UI" pitchFamily="34" charset="0"/>
                 <a:ea typeface="Segoe UI" pitchFamily="34" charset="-122"/>
@@ -3675,7 +3897,7 @@
             <a:r>
               <a:rPr lang="en-US" sz="1000" dirty="0">
                 <a:solidFill>
-                  <a:srgbClr val="6C7F6B"/>
+                  <a:srgbClr val="75897D"/>
                 </a:solidFill>
               </a:rPr>
               <a:t>nextrole  ·  2/10</a:t>
@@ -3957,7 +4179,7 @@
             <a:avLst/>
           </a:prstGeom>
           <a:solidFill>
-            <a:srgbClr val="E2603B"/>
+            <a:srgbClr val="E2603C"/>
           </a:solidFill>
           <a:ln/>
         </p:spPr>
@@ -3989,7 +4211,7 @@
             <a:r>
               <a:rPr lang="en-US" sz="1300" b="1" spc="300" kern="0" dirty="0">
                 <a:solidFill>
-                  <a:srgbClr val="E2603B"/>
+                  <a:srgbClr val="E2603C"/>
                 </a:solidFill>
                 <a:latin typeface="Segoe UI" pitchFamily="34" charset="0"/>
                 <a:ea typeface="Segoe UI" pitchFamily="34" charset="-122"/>
@@ -4028,7 +4250,7 @@
             <a:r>
               <a:rPr lang="en-US" sz="3400" b="1" dirty="0">
                 <a:solidFill>
-                  <a:srgbClr val="13211B"/>
+                  <a:srgbClr val="11372A"/>
                 </a:solidFill>
                 <a:latin typeface="Segoe UI" pitchFamily="34" charset="0"/>
                 <a:ea typeface="Segoe UI" pitchFamily="34" charset="-122"/>
@@ -4061,7 +4283,7 @@
           </a:solidFill>
           <a:ln w="19050">
             <a:solidFill>
-              <a:srgbClr val="ECE9DB"/>
+              <a:srgbClr val="F1EFE6"/>
             </a:solidFill>
             <a:prstDash val="solid"/>
           </a:ln>
@@ -4094,7 +4316,7 @@
             <a:r>
               <a:rPr lang="en-US" sz="2000" b="1" dirty="0">
                 <a:solidFill>
-                  <a:srgbClr val="E2603B"/>
+                  <a:srgbClr val="E2603C"/>
                 </a:solidFill>
                 <a:latin typeface="Segoe UI" pitchFamily="34" charset="0"/>
                 <a:ea typeface="Segoe UI" pitchFamily="34" charset="-122"/>
@@ -4133,13 +4355,13 @@
             <a:r>
               <a:rPr lang="en-US" sz="1400" dirty="0">
                 <a:solidFill>
-                  <a:srgbClr val="13211B"/>
+                  <a:srgbClr val="11372A"/>
                 </a:solidFill>
                 <a:latin typeface="Segoe UI" pitchFamily="34" charset="0"/>
                 <a:ea typeface="Segoe UI" pitchFamily="34" charset="-122"/>
                 <a:cs typeface="Segoe UI" pitchFamily="34" charset="-120"/>
               </a:rPr>
-              <a:t>PDF, DOCX, TXT - or paste text. Scans are read with OCR.</a:t>
+              <a:t>PDF, DOCX, TXT - or paste text. Scanned pages are read with OCR, right in the browser.</a:t>
             </a:r>
             <a:endParaRPr lang="en-US" sz="1400" dirty="0"/>
           </a:p>
@@ -4166,7 +4388,7 @@
           </a:solidFill>
           <a:ln w="19050">
             <a:solidFill>
-              <a:srgbClr val="ECE9DB"/>
+              <a:srgbClr val="F1EFE6"/>
             </a:solidFill>
             <a:prstDash val="solid"/>
           </a:ln>
@@ -4199,7 +4421,7 @@
             <a:r>
               <a:rPr lang="en-US" sz="2000" b="1" dirty="0">
                 <a:solidFill>
-                  <a:srgbClr val="E2603B"/>
+                  <a:srgbClr val="E2603C"/>
                 </a:solidFill>
                 <a:latin typeface="Segoe UI" pitchFamily="34" charset="0"/>
                 <a:ea typeface="Segoe UI" pitchFamily="34" charset="-122"/>
@@ -4238,13 +4460,13 @@
             <a:r>
               <a:rPr lang="en-US" sz="1400" dirty="0">
                 <a:solidFill>
-                  <a:srgbClr val="13211B"/>
+                  <a:srgbClr val="11372A"/>
                 </a:solidFill>
                 <a:latin typeface="Segoe UI" pitchFamily="34" charset="0"/>
                 <a:ea typeface="Segoe UI" pitchFamily="34" charset="-122"/>
                 <a:cs typeface="Segoe UI" pitchFamily="34" charset="-120"/>
               </a:rPr>
-              <a:t>163-skill catalogue + 30-role library scored in seconds. Grok AI optional.</a:t>
+              <a:t>163-skill catalogue + 30-role library scored in seconds. Grok AI upgrades it when a key is set.</a:t>
             </a:r>
             <a:endParaRPr lang="en-US" sz="1400" dirty="0"/>
           </a:p>
@@ -4271,7 +4493,7 @@
           </a:solidFill>
           <a:ln w="19050">
             <a:solidFill>
-              <a:srgbClr val="ECE9DB"/>
+              <a:srgbClr val="F1EFE6"/>
             </a:solidFill>
             <a:prstDash val="solid"/>
           </a:ln>
@@ -4304,7 +4526,7 @@
             <a:r>
               <a:rPr lang="en-US" sz="2000" b="1" dirty="0">
                 <a:solidFill>
-                  <a:srgbClr val="E2603B"/>
+                  <a:srgbClr val="E2603C"/>
                 </a:solidFill>
                 <a:latin typeface="Segoe UI" pitchFamily="34" charset="0"/>
                 <a:ea typeface="Segoe UI" pitchFamily="34" charset="-122"/>
@@ -4343,13 +4565,13 @@
             <a:r>
               <a:rPr lang="en-US" sz="1400" dirty="0">
                 <a:solidFill>
-                  <a:srgbClr val="13211B"/>
+                  <a:srgbClr val="11372A"/>
                 </a:solidFill>
                 <a:latin typeface="Segoe UI" pitchFamily="34" charset="0"/>
                 <a:ea typeface="Segoe UI" pitchFamily="34" charset="-122"/>
                 <a:cs typeface="Segoe UI" pitchFamily="34" charset="-120"/>
               </a:rPr>
-              <a:t>Ranked roles with match %, plain-English reasons, and skill checklists.</a:t>
+              <a:t>Ranked roles with match %, plain-English reasons, and a required-skills checklist per role.</a:t>
             </a:r>
             <a:endParaRPr lang="en-US" sz="1400" dirty="0"/>
           </a:p>
@@ -4382,7 +4604,7 @@
             <a:r>
               <a:rPr lang="en-US" sz="1700" i="1" dirty="0">
                 <a:solidFill>
-                  <a:srgbClr val="6C7F6B"/>
+                  <a:srgbClr val="75897D"/>
                 </a:solidFill>
                 <a:latin typeface="Segoe UI" pitchFamily="34" charset="0"/>
                 <a:ea typeface="Segoe UI" pitchFamily="34" charset="-122"/>
@@ -4421,7 +4643,7 @@
             <a:r>
               <a:rPr lang="en-US" sz="1000" dirty="0">
                 <a:solidFill>
-                  <a:srgbClr val="6C7F6B"/>
+                  <a:srgbClr val="75897D"/>
                 </a:solidFill>
               </a:rPr>
               <a:t>nextrole  ·  3/10</a:t>
@@ -5018,7 +5240,7 @@
             <a:avLst/>
           </a:prstGeom>
           <a:solidFill>
-            <a:srgbClr val="E2603B"/>
+            <a:srgbClr val="E2603C"/>
           </a:solidFill>
           <a:ln/>
         </p:spPr>
@@ -5050,7 +5272,7 @@
             <a:r>
               <a:rPr lang="en-US" sz="1300" b="1" spc="300" kern="0" dirty="0">
                 <a:solidFill>
-                  <a:srgbClr val="E2603B"/>
+                  <a:srgbClr val="E2603C"/>
                 </a:solidFill>
                 <a:latin typeface="Segoe UI" pitchFamily="34" charset="0"/>
                 <a:ea typeface="Segoe UI" pitchFamily="34" charset="-122"/>
@@ -5089,7 +5311,7 @@
             <a:r>
               <a:rPr lang="en-US" sz="3400" b="1" dirty="0">
                 <a:solidFill>
-                  <a:srgbClr val="13211B"/>
+                  <a:srgbClr val="11372A"/>
                 </a:solidFill>
                 <a:latin typeface="Segoe UI" pitchFamily="34" charset="0"/>
                 <a:ea typeface="Segoe UI" pitchFamily="34" charset="-122"/>
@@ -5132,7 +5354,7 @@
             <a:r>
               <a:rPr lang="en-US" sz="1800" dirty="0">
                 <a:solidFill>
-                  <a:srgbClr val="13211B"/>
+                  <a:srgbClr val="11372A"/>
                 </a:solidFill>
                 <a:latin typeface="Segoe UI" pitchFamily="34" charset="0"/>
                 <a:ea typeface="Segoe UI" pitchFamily="34" charset="-122"/>
@@ -5153,7 +5375,7 @@
             <a:r>
               <a:rPr lang="en-US" sz="1800" dirty="0">
                 <a:solidFill>
-                  <a:srgbClr val="13211B"/>
+                  <a:srgbClr val="11372A"/>
                 </a:solidFill>
                 <a:latin typeface="Segoe UI" pitchFamily="34" charset="0"/>
                 <a:ea typeface="Segoe UI" pitchFamily="34" charset="-122"/>
@@ -5174,13 +5396,13 @@
             <a:r>
               <a:rPr lang="en-US" sz="1800" dirty="0">
                 <a:solidFill>
-                  <a:srgbClr val="13211B"/>
+                  <a:srgbClr val="11372A"/>
                 </a:solidFill>
                 <a:latin typeface="Segoe UI" pitchFamily="34" charset="0"/>
                 <a:ea typeface="Segoe UI" pitchFamily="34" charset="-122"/>
                 <a:cs typeface="Segoe UI" pitchFamily="34" charset="-120"/>
               </a:rPr>
-              <a:t>Engine 3 - Tesseract OCR: renders each page as an image and reads it like eyes - rescues scanned / photographed resumes with no text layer.</a:t>
+              <a:t>Engine 3 - Tesseract OCR: renders each page as an image and reads it like eyes - rescues scanned or photographed resumes with no text layer.</a:t>
             </a:r>
             <a:endParaRPr lang="en-US" sz="1800" dirty="0"/>
           </a:p>
@@ -5195,7 +5417,7 @@
             <a:r>
               <a:rPr lang="en-US" sz="1800" dirty="0">
                 <a:solidFill>
-                  <a:srgbClr val="13211B"/>
+                  <a:srgbClr val="11372A"/>
                 </a:solidFill>
                 <a:latin typeface="Segoe UI" pitchFamily="34" charset="0"/>
                 <a:ea typeface="Segoe UI" pitchFamily="34" charset="-122"/>
@@ -5216,7 +5438,7 @@
             <a:r>
               <a:rPr lang="en-US" sz="1800" dirty="0">
                 <a:solidFill>
-                  <a:srgbClr val="13211B"/>
+                  <a:srgbClr val="11372A"/>
                 </a:solidFill>
                 <a:latin typeface="Segoe UI" pitchFamily="34" charset="0"/>
                 <a:ea typeface="Segoe UI" pitchFamily="34" charset="-122"/>
@@ -5255,7 +5477,7 @@
             <a:r>
               <a:rPr lang="en-US" sz="1000" dirty="0">
                 <a:solidFill>
-                  <a:srgbClr val="6C7F6B"/>
+                  <a:srgbClr val="75897D"/>
                 </a:solidFill>
               </a:rPr>
               <a:t>nextrole  ·  4/10</a:t>
@@ -5537,7 +5759,7 @@
             <a:avLst/>
           </a:prstGeom>
           <a:solidFill>
-            <a:srgbClr val="E2603B"/>
+            <a:srgbClr val="E2603C"/>
           </a:solidFill>
           <a:ln/>
         </p:spPr>
@@ -5569,7 +5791,7 @@
             <a:r>
               <a:rPr lang="en-US" sz="1300" b="1" spc="300" kern="0" dirty="0">
                 <a:solidFill>
-                  <a:srgbClr val="E2603B"/>
+                  <a:srgbClr val="E2603C"/>
                 </a:solidFill>
                 <a:latin typeface="Segoe UI" pitchFamily="34" charset="0"/>
                 <a:ea typeface="Segoe UI" pitchFamily="34" charset="-122"/>
@@ -5608,7 +5830,7 @@
             <a:r>
               <a:rPr lang="en-US" sz="3400" b="1" dirty="0">
                 <a:solidFill>
-                  <a:srgbClr val="13211B"/>
+                  <a:srgbClr val="11372A"/>
                 </a:solidFill>
                 <a:latin typeface="Segoe UI" pitchFamily="34" charset="0"/>
                 <a:ea typeface="Segoe UI" pitchFamily="34" charset="-122"/>
@@ -5651,7 +5873,7 @@
             <a:r>
               <a:rPr lang="en-US" sz="1800" dirty="0">
                 <a:solidFill>
-                  <a:srgbClr val="13211B"/>
+                  <a:srgbClr val="11372A"/>
                 </a:solidFill>
                 <a:latin typeface="Segoe UI" pitchFamily="34" charset="0"/>
                 <a:ea typeface="Segoe UI" pitchFamily="34" charset="-122"/>
@@ -5672,7 +5894,7 @@
             <a:r>
               <a:rPr lang="en-US" sz="1800" dirty="0">
                 <a:solidFill>
-                  <a:srgbClr val="13211B"/>
+                  <a:srgbClr val="11372A"/>
                 </a:solidFill>
                 <a:latin typeface="Segoe UI" pitchFamily="34" charset="0"/>
                 <a:ea typeface="Segoe UI" pitchFamily="34" charset="-122"/>
@@ -5693,7 +5915,7 @@
             <a:r>
               <a:rPr lang="en-US" sz="1800" dirty="0">
                 <a:solidFill>
-                  <a:srgbClr val="13211B"/>
+                  <a:srgbClr val="11372A"/>
                 </a:solidFill>
                 <a:latin typeface="Segoe UI" pitchFamily="34" charset="0"/>
                 <a:ea typeface="Segoe UI" pitchFamily="34" charset="-122"/>
@@ -5714,7 +5936,7 @@
             <a:r>
               <a:rPr lang="en-US" sz="1800" dirty="0">
                 <a:solidFill>
-                  <a:srgbClr val="13211B"/>
+                  <a:srgbClr val="11372A"/>
                 </a:solidFill>
                 <a:latin typeface="Segoe UI" pitchFamily="34" charset="0"/>
                 <a:ea typeface="Segoe UI" pitchFamily="34" charset="-122"/>
@@ -5735,13 +5957,13 @@
             <a:r>
               <a:rPr lang="en-US" sz="1800" dirty="0">
                 <a:solidFill>
-                  <a:srgbClr val="13211B"/>
+                  <a:srgbClr val="11372A"/>
                 </a:solidFill>
                 <a:latin typeface="Segoe UI" pitchFamily="34" charset="0"/>
                 <a:ea typeface="Segoe UI" pitchFamily="34" charset="-122"/>
                 <a:cs typeface="Segoe UI" pitchFamily="34" charset="-120"/>
               </a:rPr>
-              <a:t>Grok AI upgrades the same flow when GROK_API_KEY is set - local matcher is the safety net.</a:t>
+              <a:t>Grok AI upgrades the same flow when GROK_API_KEY is set - the local matcher is the safety net.</a:t>
             </a:r>
             <a:endParaRPr lang="en-US" sz="1800" dirty="0"/>
           </a:p>
@@ -5774,7 +5996,7 @@
             <a:r>
               <a:rPr lang="en-US" sz="1000" dirty="0">
                 <a:solidFill>
-                  <a:srgbClr val="6C7F6B"/>
+                  <a:srgbClr val="75897D"/>
                 </a:solidFill>
               </a:rPr>
               <a:t>nextrole  ·  5/10</a:t>
@@ -6056,7 +6278,7 @@
             <a:avLst/>
           </a:prstGeom>
           <a:solidFill>
-            <a:srgbClr val="E2603B"/>
+            <a:srgbClr val="E2603C"/>
           </a:solidFill>
           <a:ln/>
         </p:spPr>
@@ -6088,7 +6310,7 @@
             <a:r>
               <a:rPr lang="en-US" sz="1300" b="1" spc="300" kern="0" dirty="0">
                 <a:solidFill>
-                  <a:srgbClr val="E2603B"/>
+                  <a:srgbClr val="E2603C"/>
                 </a:solidFill>
                 <a:latin typeface="Segoe UI" pitchFamily="34" charset="0"/>
                 <a:ea typeface="Segoe UI" pitchFamily="34" charset="-122"/>
@@ -6127,7 +6349,7 @@
             <a:r>
               <a:rPr lang="en-US" sz="3400" b="1" dirty="0">
                 <a:solidFill>
-                  <a:srgbClr val="13211B"/>
+                  <a:srgbClr val="11372A"/>
                 </a:solidFill>
                 <a:latin typeface="Segoe UI" pitchFamily="34" charset="0"/>
                 <a:ea typeface="Segoe UI" pitchFamily="34" charset="-122"/>
@@ -6160,7 +6382,7 @@
           </a:solidFill>
           <a:ln w="19050">
             <a:solidFill>
-              <a:srgbClr val="ECE9DB"/>
+              <a:srgbClr val="F1EFE6"/>
             </a:solidFill>
             <a:prstDash val="solid"/>
           </a:ln>
@@ -6193,7 +6415,7 @@
             <a:r>
               <a:rPr lang="en-US" sz="2000" b="1" dirty="0">
                 <a:solidFill>
-                  <a:srgbClr val="11372A"/>
+                  <a:srgbClr val="123A2B"/>
                 </a:solidFill>
                 <a:latin typeface="Segoe UI" pitchFamily="34" charset="0"/>
                 <a:ea typeface="Segoe UI" pitchFamily="34" charset="-122"/>
@@ -6232,13 +6454,13 @@
             <a:r>
               <a:rPr lang="en-US" sz="1400" dirty="0">
                 <a:solidFill>
-                  <a:srgbClr val="13211B"/>
+                  <a:srgbClr val="11372A"/>
                 </a:solidFill>
                 <a:latin typeface="Segoe UI" pitchFamily="34" charset="0"/>
                 <a:ea typeface="Segoe UI" pitchFamily="34" charset="-122"/>
                 <a:cs typeface="Segoe UI" pitchFamily="34" charset="-120"/>
               </a:rPr>
-              <a:t>The landing interface: hero, dark-green upload card, and "Roles for you" results panel.</a:t>
+              <a:t>The landing interface: hero, dark-green upload card, and the "Roles for you" results panel.</a:t>
             </a:r>
             <a:endParaRPr lang="en-US" sz="1400" dirty="0"/>
           </a:p>
@@ -6265,7 +6487,7 @@
           </a:solidFill>
           <a:ln w="19050">
             <a:solidFill>
-              <a:srgbClr val="ECE9DB"/>
+              <a:srgbClr val="F1EFE6"/>
             </a:solidFill>
             <a:prstDash val="solid"/>
           </a:ln>
@@ -6298,7 +6520,7 @@
             <a:r>
               <a:rPr lang="en-US" sz="2000" b="1" dirty="0">
                 <a:solidFill>
-                  <a:srgbClr val="11372A"/>
+                  <a:srgbClr val="123A2B"/>
                 </a:solidFill>
                 <a:latin typeface="Segoe UI" pitchFamily="34" charset="0"/>
                 <a:ea typeface="Segoe UI" pitchFamily="34" charset="-122"/>
@@ -6337,7 +6559,7 @@
             <a:r>
               <a:rPr lang="en-US" sz="1400" dirty="0">
                 <a:solidFill>
-                  <a:srgbClr val="13211B"/>
+                  <a:srgbClr val="11372A"/>
                 </a:solidFill>
                 <a:latin typeface="Segoe UI" pitchFamily="34" charset="0"/>
                 <a:ea typeface="Segoe UI" pitchFamily="34" charset="-122"/>
@@ -6370,7 +6592,7 @@
           </a:solidFill>
           <a:ln w="19050">
             <a:solidFill>
-              <a:srgbClr val="ECE9DB"/>
+              <a:srgbClr val="F1EFE6"/>
             </a:solidFill>
             <a:prstDash val="solid"/>
           </a:ln>
@@ -6403,7 +6625,7 @@
             <a:r>
               <a:rPr lang="en-US" sz="2000" b="1" dirty="0">
                 <a:solidFill>
-                  <a:srgbClr val="11372A"/>
+                  <a:srgbClr val="123A2B"/>
                 </a:solidFill>
                 <a:latin typeface="Segoe UI" pitchFamily="34" charset="0"/>
                 <a:ea typeface="Segoe UI" pitchFamily="34" charset="-122"/>
@@ -6442,13 +6664,13 @@
             <a:r>
               <a:rPr lang="en-US" sz="1400" dirty="0">
                 <a:solidFill>
-                  <a:srgbClr val="13211B"/>
+                  <a:srgbClr val="11372A"/>
                 </a:solidFill>
                 <a:latin typeface="Segoe UI" pitchFamily="34" charset="0"/>
                 <a:ea typeface="Segoe UI" pitchFamily="34" charset="-122"/>
                 <a:cs typeface="Segoe UI" pitchFamily="34" charset="-120"/>
               </a:rPr>
-              <a:t>Saved analyses, top match, dates, filenames - history you control, deletable anytime.</a:t>
+              <a:t>Sign in with email + password, then find saved analyses, top match, dates and filenames - deletable anytime.</a:t>
             </a:r>
             <a:endParaRPr lang="en-US" sz="1400" dirty="0"/>
           </a:p>
@@ -6481,7 +6703,7 @@
             <a:r>
               <a:rPr lang="en-US" sz="1000" dirty="0">
                 <a:solidFill>
-                  <a:srgbClr val="6C7F6B"/>
+                  <a:srgbClr val="75897D"/>
                 </a:solidFill>
               </a:rPr>
               <a:t>nextrole  ·  6/10</a:t>
@@ -7043,7 +7265,7 @@
             <a:avLst/>
           </a:prstGeom>
           <a:solidFill>
-            <a:srgbClr val="E2603B"/>
+            <a:srgbClr val="E2603C"/>
           </a:solidFill>
           <a:ln/>
         </p:spPr>
@@ -7075,7 +7297,7 @@
             <a:r>
               <a:rPr lang="en-US" sz="1300" b="1" spc="300" kern="0" dirty="0">
                 <a:solidFill>
-                  <a:srgbClr val="E2603B"/>
+                  <a:srgbClr val="E2603C"/>
                 </a:solidFill>
                 <a:latin typeface="Segoe UI" pitchFamily="34" charset="0"/>
                 <a:ea typeface="Segoe UI" pitchFamily="34" charset="-122"/>
@@ -7114,7 +7336,7 @@
             <a:r>
               <a:rPr lang="en-US" sz="3400" b="1" dirty="0">
                 <a:solidFill>
-                  <a:srgbClr val="13211B"/>
+                  <a:srgbClr val="11372A"/>
                 </a:solidFill>
                 <a:latin typeface="Segoe UI" pitchFamily="34" charset="0"/>
                 <a:ea typeface="Segoe UI" pitchFamily="34" charset="-122"/>
@@ -7157,7 +7379,7 @@
             <a:r>
               <a:rPr lang="en-US" sz="1800" dirty="0">
                 <a:solidFill>
-                  <a:srgbClr val="13211B"/>
+                  <a:srgbClr val="11372A"/>
                 </a:solidFill>
                 <a:latin typeface="Segoe UI" pitchFamily="34" charset="0"/>
                 <a:ea typeface="Segoe UI" pitchFamily="34" charset="-122"/>
@@ -7178,13 +7400,13 @@
             <a:r>
               <a:rPr lang="en-US" sz="1800" dirty="0">
                 <a:solidFill>
-                  <a:srgbClr val="13211B"/>
+                  <a:srgbClr val="11372A"/>
                 </a:solidFill>
                 <a:latin typeface="Segoe UI" pitchFamily="34" charset="0"/>
                 <a:ea typeface="Segoe UI" pitchFamily="34" charset="-122"/>
                 <a:cs typeface="Segoe UI" pitchFamily="34" charset="-120"/>
               </a:rPr>
-              <a:t>Roles matched to your resume float to the top with an orange % match badge.</a:t>
+              <a:t>Match percentages appear ONLY after you upload or paste a resume - never before.</a:t>
             </a:r>
             <a:endParaRPr lang="en-US" sz="1800" dirty="0"/>
           </a:p>
@@ -7199,13 +7421,13 @@
             <a:r>
               <a:rPr lang="en-US" sz="1800" dirty="0">
                 <a:solidFill>
-                  <a:srgbClr val="13211B"/>
+                  <a:srgbClr val="11372A"/>
                 </a:solidFill>
                 <a:latin typeface="Segoe UI" pitchFamily="34" charset="0"/>
                 <a:ea typeface="Segoe UI" pitchFamily="34" charset="-122"/>
                 <a:cs typeface="Segoe UI" pitchFamily="34" charset="-120"/>
               </a:rPr>
-              <a:t>The selector lists every role; choosing one reveals its full required-skills checklist.</a:t>
+              <a:t>Once analysed, matched roles float to the top with an orange % match badge.</a:t>
             </a:r>
             <a:endParaRPr lang="en-US" sz="1800" dirty="0"/>
           </a:p>
@@ -7220,13 +7442,13 @@
             <a:r>
               <a:rPr lang="en-US" sz="1800" dirty="0">
                 <a:solidFill>
-                  <a:srgbClr val="13211B"/>
+                  <a:srgbClr val="11372A"/>
                 </a:solidFill>
                 <a:latin typeface="Segoe UI" pitchFamily="34" charset="0"/>
                 <a:ea typeface="Segoe UI" pitchFamily="34" charset="-122"/>
                 <a:cs typeface="Segoe UI" pitchFamily="34" charset="-120"/>
               </a:rPr>
-              <a:t>Skills you already have are ticked: "You have 4 of 9 skills" with a progress line.</a:t>
+              <a:t>The selector lists every role; choosing one reveals its full required-skills checklist.</a:t>
             </a:r>
             <a:endParaRPr lang="en-US" sz="1800" dirty="0"/>
           </a:p>
@@ -7241,13 +7463,13 @@
             <a:r>
               <a:rPr lang="en-US" sz="1800" dirty="0">
                 <a:solidFill>
-                  <a:srgbClr val="13211B"/>
+                  <a:srgbClr val="11372A"/>
                 </a:solidFill>
                 <a:latin typeface="Segoe UI" pitchFamily="34" charset="0"/>
                 <a:ea typeface="Segoe UI" pitchFamily="34" charset="-122"/>
                 <a:cs typeface="Segoe UI" pitchFamily="34" charset="-120"/>
               </a:rPr>
-              <a:t>Every card links to a full detail page with fit breakdown and next-step CTA.</a:t>
+              <a:t>Skills you already have are ticked: "You have 4 of 9 skills" with a progress line.</a:t>
             </a:r>
             <a:endParaRPr lang="en-US" sz="1800" dirty="0"/>
           </a:p>
@@ -7280,7 +7502,7 @@
             <a:r>
               <a:rPr lang="en-US" sz="1000" dirty="0">
                 <a:solidFill>
-                  <a:srgbClr val="6C7F6B"/>
+                  <a:srgbClr val="75897D"/>
                 </a:solidFill>
               </a:rPr>
               <a:t>nextrole  ·  7/10</a:t>
@@ -7562,7 +7784,7 @@
             <a:avLst/>
           </a:prstGeom>
           <a:solidFill>
-            <a:srgbClr val="E2603B"/>
+            <a:srgbClr val="E2603C"/>
           </a:solidFill>
           <a:ln/>
         </p:spPr>
@@ -7594,7 +7816,7 @@
             <a:r>
               <a:rPr lang="en-US" sz="1300" b="1" spc="300" kern="0" dirty="0">
                 <a:solidFill>
-                  <a:srgbClr val="E2603B"/>
+                  <a:srgbClr val="E2603C"/>
                 </a:solidFill>
                 <a:latin typeface="Segoe UI" pitchFamily="34" charset="0"/>
                 <a:ea typeface="Segoe UI" pitchFamily="34" charset="-122"/>
@@ -7633,13 +7855,13 @@
             <a:r>
               <a:rPr lang="en-US" sz="3400" b="1" dirty="0">
                 <a:solidFill>
-                  <a:srgbClr val="13211B"/>
+                  <a:srgbClr val="11372A"/>
                 </a:solidFill>
                 <a:latin typeface="Segoe UI" pitchFamily="34" charset="0"/>
                 <a:ea typeface="Segoe UI" pitchFamily="34" charset="-122"/>
                 <a:cs typeface="Segoe UI" pitchFamily="34" charset="-120"/>
               </a:rPr>
-              <a:t>Secure sign-in, zero lock-in</a:t>
+              <a:t>Secure sign-in, everywhere</a:t>
             </a:r>
             <a:endParaRPr lang="en-US" sz="3400" dirty="0"/>
           </a:p>
@@ -7676,13 +7898,13 @@
             <a:r>
               <a:rPr lang="en-US" sz="1800" dirty="0">
                 <a:solidFill>
-                  <a:srgbClr val="13211B"/>
+                  <a:srgbClr val="11372A"/>
                 </a:solidFill>
                 <a:latin typeface="Segoe UI" pitchFamily="34" charset="0"/>
                 <a:ea typeface="Segoe UI" pitchFamily="34" charset="-122"/>
                 <a:cs typeface="Segoe UI" pitchFamily="34" charset="-120"/>
               </a:rPr>
-              <a:t>Sign up: name + email + password. Sign in: email + password.</a:t>
+              <a:t>Sign up: name + email + password. Sign in: email + password - on the web app AND the desktop app.</a:t>
             </a:r>
             <a:endParaRPr lang="en-US" sz="1800" dirty="0"/>
           </a:p>
@@ -7697,13 +7919,13 @@
             <a:r>
               <a:rPr lang="en-US" sz="1800" dirty="0">
                 <a:solidFill>
-                  <a:srgbClr val="13211B"/>
+                  <a:srgbClr val="11372A"/>
                 </a:solidFill>
                 <a:latin typeface="Segoe UI" pitchFamily="34" charset="0"/>
                 <a:ea typeface="Segoe UI" pitchFamily="34" charset="-122"/>
                 <a:cs typeface="Segoe UI" pitchFamily="34" charset="-120"/>
               </a:rPr>
-              <a:t>Passwords hashed with scrypt (salted, constant-time compare) - never stored raw.</a:t>
+              <a:t>Full app: passwords hashed with scrypt (salted, constant-time compare); JWT sessions; MongoDB or file store.</a:t>
             </a:r>
             <a:endParaRPr lang="en-US" sz="1800" dirty="0"/>
           </a:p>
@@ -7718,13 +7940,13 @@
             <a:r>
               <a:rPr lang="en-US" sz="1800" dirty="0">
                 <a:solidFill>
-                  <a:srgbClr val="13211B"/>
+                  <a:srgbClr val="11372A"/>
                 </a:solidFill>
                 <a:latin typeface="Segoe UI" pitchFamily="34" charset="0"/>
                 <a:ea typeface="Segoe UI" pitchFamily="34" charset="-122"/>
                 <a:cs typeface="Segoe UI" pitchFamily="34" charset="-120"/>
               </a:rPr>
-              <a:t>Clear handling of wrong password, duplicate sign-up, and unknown email.</a:t>
+              <a:t>Hosted app: browser-local accounts hashed with salted SHA-256 via WebCrypto - resumes never leave the device.</a:t>
             </a:r>
             <a:endParaRPr lang="en-US" sz="1800" dirty="0"/>
           </a:p>
@@ -7739,7 +7961,7 @@
             <a:r>
               <a:rPr lang="en-US" sz="1800" dirty="0">
                 <a:solidFill>
-                  <a:srgbClr val="13211B"/>
+                  <a:srgbClr val="11372A"/>
                 </a:solidFill>
                 <a:latin typeface="Segoe UI" pitchFamily="34" charset="0"/>
                 <a:ea typeface="Segoe UI" pitchFamily="34" charset="-122"/>
@@ -7760,13 +7982,13 @@
             <a:r>
               <a:rPr lang="en-US" sz="1800" dirty="0">
                 <a:solidFill>
-                  <a:srgbClr val="13211B"/>
+                  <a:srgbClr val="11372A"/>
                 </a:solidFill>
                 <a:latin typeface="Segoe UI" pitchFamily="34" charset="0"/>
                 <a:ea typeface="Segoe UI" pitchFamily="34" charset="-122"/>
                 <a:cs typeface="Segoe UI" pitchFamily="34" charset="-120"/>
               </a:rPr>
-              <a:t>JWT sessions; MongoDB when configured, else a file store inside nextrole.json.</a:t>
+              <a:t>Session-scoped results: percentages never linger across visits.</a:t>
             </a:r>
             <a:endParaRPr lang="en-US" sz="1800" dirty="0"/>
           </a:p>
@@ -7799,7 +8021,7 @@
             <a:r>
               <a:rPr lang="en-US" sz="1000" dirty="0">
                 <a:solidFill>
-                  <a:srgbClr val="6C7F6B"/>
+                  <a:srgbClr val="75897D"/>
                 </a:solidFill>
               </a:rPr>
               <a:t>nextrole  ·  8/10</a:t>
@@ -8081,7 +8303,7 @@
             <a:avLst/>
           </a:prstGeom>
           <a:solidFill>
-            <a:srgbClr val="E2603B"/>
+            <a:srgbClr val="E2603C"/>
           </a:solidFill>
           <a:ln/>
         </p:spPr>
@@ -8113,7 +8335,7 @@
             <a:r>
               <a:rPr lang="en-US" sz="1300" b="1" spc="300" kern="0" dirty="0">
                 <a:solidFill>
-                  <a:srgbClr val="E2603B"/>
+                  <a:srgbClr val="E2603C"/>
                 </a:solidFill>
                 <a:latin typeface="Segoe UI" pitchFamily="34" charset="0"/>
                 <a:ea typeface="Segoe UI" pitchFamily="34" charset="-122"/>
@@ -8152,13 +8374,13 @@
             <a:r>
               <a:rPr lang="en-US" sz="3400" b="1" dirty="0">
                 <a:solidFill>
-                  <a:srgbClr val="13211B"/>
+                  <a:srgbClr val="11372A"/>
                 </a:solidFill>
                 <a:latin typeface="Segoe UI" pitchFamily="34" charset="0"/>
                 <a:ea typeface="Segoe UI" pitchFamily="34" charset="-122"/>
                 <a:cs typeface="Segoe UI" pitchFamily="34" charset="-120"/>
               </a:rPr>
-              <a:t>Web app + desktop app</a:t>
+              <a:t>Web, hosted, and desktop</a:t>
             </a:r>
             <a:endParaRPr lang="en-US" sz="3400" dirty="0"/>
           </a:p>
@@ -8195,13 +8417,13 @@
             <a:r>
               <a:rPr lang="en-US" sz="1800" dirty="0">
                 <a:solidFill>
-                  <a:srgbClr val="13211B"/>
+                  <a:srgbClr val="11372A"/>
                 </a:solidFill>
                 <a:latin typeface="Segoe UI" pitchFamily="34" charset="0"/>
                 <a:ea typeface="Segoe UI" pitchFamily="34" charset="-122"/>
                 <a:cs typeface="Segoe UI" pitchFamily="34" charset="-120"/>
               </a:rPr>
-              <a:t>Dev mode: Vite dev server + API (npm run dev).</a:t>
+              <a:t>Live web app: saxenavansh070-droid.github.io/nextrole - full analysis in the browser, zero setup.</a:t>
             </a:r>
             <a:endParaRPr lang="en-US" sz="1800" dirty="0"/>
           </a:p>
@@ -8216,13 +8438,13 @@
             <a:r>
               <a:rPr lang="en-US" sz="1800" dirty="0">
                 <a:solidFill>
-                  <a:srgbClr val="13211B"/>
+                  <a:srgbClr val="11372A"/>
                 </a:solidFill>
                 <a:latin typeface="Segoe UI" pitchFamily="34" charset="0"/>
                 <a:ea typeface="Segoe UI" pitchFamily="34" charset="-122"/>
                 <a:cs typeface="Segoe UI" pitchFamily="34" charset="-120"/>
               </a:rPr>
-              <a:t>Production: one Node process serves UI + API from the same origin.</a:t>
+              <a:t>Local full stack: one Node process serves UI + API (npm run dev, or build + start).</a:t>
             </a:r>
             <a:endParaRPr lang="en-US" sz="1800" dirty="0"/>
           </a:p>
@@ -8237,13 +8459,13 @@
             <a:r>
               <a:rPr lang="en-US" sz="1800" dirty="0">
                 <a:solidFill>
-                  <a:srgbClr val="13211B"/>
+                  <a:srgbClr val="11372A"/>
                 </a:solidFill>
                 <a:latin typeface="Segoe UI" pitchFamily="34" charset="0"/>
                 <a:ea typeface="Segoe UI" pitchFamily="34" charset="-122"/>
                 <a:cs typeface="Segoe UI" pitchFamily="34" charset="-120"/>
               </a:rPr>
-              <a:t>Desktop: Electron wrapper - Next Role.exe opens the app in its own window, bundled server included.</a:t>
+              <a:t>Desktop: Electron wrapper - installs in one click via NextRole-Setup.exe, bundled server included.</a:t>
             </a:r>
             <a:endParaRPr lang="en-US" sz="1800" dirty="0"/>
           </a:p>
@@ -8258,13 +8480,13 @@
             <a:r>
               <a:rPr lang="en-US" sz="1800" dirty="0">
                 <a:solidFill>
-                  <a:srgbClr val="13211B"/>
+                  <a:srgbClr val="11372A"/>
                 </a:solidFill>
                 <a:latin typeface="Segoe UI" pitchFamily="34" charset="0"/>
                 <a:ea typeface="Segoe UI" pitchFamily="34" charset="-122"/>
                 <a:cs typeface="Segoe UI" pitchFamily="34" charset="-120"/>
               </a:rPr>
-              <a:t>Portable Windows build via electron-builder (no installer, no signing needed).</a:t>
+              <a:t>Icons, fonts and OCR language data bundle offline; Grok and MongoDB stay optional.</a:t>
             </a:r>
             <a:endParaRPr lang="en-US" sz="1800" dirty="0"/>
           </a:p>
@@ -8279,13 +8501,13 @@
             <a:r>
               <a:rPr lang="en-US" sz="1800" dirty="0">
                 <a:solidFill>
-                  <a:srgbClr val="13211B"/>
+                  <a:srgbClr val="11372A"/>
                 </a:solidFill>
                 <a:latin typeface="Segoe UI" pitchFamily="34" charset="0"/>
                 <a:ea typeface="Segoe UI" pitchFamily="34" charset="-122"/>
                 <a:cs typeface="Segoe UI" pitchFamily="34" charset="-120"/>
               </a:rPr>
-              <a:t>Graceful everywhere: runs fully without MongoDB, Grok, or Google keys.</a:t>
+              <a:t>Same codebase, same matching engine, three surfaces.</a:t>
             </a:r>
             <a:endParaRPr lang="en-US" sz="1800" dirty="0"/>
           </a:p>
@@ -8318,7 +8540,7 @@
             <a:r>
               <a:rPr lang="en-US" sz="1000" dirty="0">
                 <a:solidFill>
-                  <a:srgbClr val="6C7F6B"/>
+                  <a:srgbClr val="75897D"/>
                 </a:solidFill>
               </a:rPr>
               <a:t>nextrole  ·  9/10</a:t>

</xml_diff>